<commit_message>
Add Raj to all code headers, fix dead crawler, FPS consistency, and report accuracy
- Add Raj Gupta NUID 002068701 to headers in model.py, train.py, collect_data.py, download_images.py
- Remove dead BingImageCrawler block in download_images.py (lines 69-73 were never used)
- Fix FPS 22-30 to 20-30 in presentation PDF, PPTX, and script
- Rename slide 6 Live Demo to Demo Capture in PPTX, PDF, and script
- Clarify glasses 87.5% comparison (vs near-zero under ViT) in report and main.tex
- Add perspective note to 3D box description in main.tex
- Add checkpoint overwrite warning to README
- Rebuild main.pdf
</commit_message>
<xml_diff>
--- a/presentation/presentation.pptx
+++ b/presentation/presentation.pptx
@@ -7239,7 +7239,7 @@
                   <a:srgbClr val="2997FF"/>
                 </a:solidFill>
               </a:rPr>
-              <a:t>LIVE DEMO</a:t>
+              <a:t>DEMO CAPTURE</a:t>
             </a:r>
           </a:p>
         </p:txBody>
@@ -7478,7 +7478,7 @@
                   <a:srgbClr val="30D158"/>
                 </a:solidFill>
               </a:rPr>
-              <a:t>22-30</a:t>
+              <a:t>20-30</a:t>
             </a:r>
           </a:p>
         </p:txBody>

</xml_diff>